<commit_message>
Add student roster QR code to Capstone 2 and 3 cover slides
PDF hosted at shared/student-roster.pdf, QR code links to GitHub Pages URL.
Added to slide 1 of both PPTX decks with label.

Co-Authored-By: Claude Opus 4.6 <noreply@anthropic.com>
</commit_message>
<xml_diff>
--- a/capstone-2/Initial-Fire-Engineer-Pump-Operations.pptx
+++ b/capstone-2/Initial-Fire-Engineer-Pump-Operations.pptx
@@ -3458,6 +3458,64 @@
                 <a:latin typeface="Calibri"/>
               </a:rPr>
               <a:t>April 28, 2026  ·  45-Minute Presentation</a:t>
+            </a:r>
+          </a:p>
+        </p:txBody>
+      </p:sp>
+      <p:pic>
+        <p:nvPicPr>
+          <p:cNvPr id="11" name="Picture 10" descr="QR-roster.png"/>
+          <p:cNvPicPr>
+            <a:picLocks noChangeAspect="1"/>
+          </p:cNvPicPr>
+          <p:nvPr/>
+        </p:nvPicPr>
+        <p:blipFill>
+          <a:blip r:embed="rId2"/>
+          <a:stretch>
+            <a:fillRect/>
+          </a:stretch>
+        </p:blipFill>
+        <p:spPr>
+          <a:xfrm>
+            <a:off x="7315200" y="5600000"/>
+            <a:ext cx="1097280" cy="1097280"/>
+          </a:xfrm>
+          <a:prstGeom prst="rect">
+            <a:avLst/>
+          </a:prstGeom>
+        </p:spPr>
+      </p:pic>
+      <p:sp>
+        <p:nvSpPr>
+          <p:cNvPr id="12" name="TextBox 11"/>
+          <p:cNvSpPr txBox="1"/>
+          <p:nvPr/>
+        </p:nvSpPr>
+        <p:spPr>
+          <a:xfrm>
+            <a:off x="7315200" y="6715280"/>
+            <a:ext cx="1097280" cy="274320"/>
+          </a:xfrm>
+          <a:prstGeom prst="rect">
+            <a:avLst/>
+          </a:prstGeom>
+          <a:noFill/>
+        </p:spPr>
+        <p:txBody>
+          <a:bodyPr wrap="square">
+            <a:spAutoFit/>
+          </a:bodyPr>
+          <a:lstStyle/>
+          <a:p>
+            <a:pPr algn="ctr"/>
+            <a:r>
+              <a:rPr sz="800" b="0">
+                <a:solidFill>
+                  <a:srgbClr val="666666"/>
+                </a:solidFill>
+              </a:rPr>
+              <a:t>Student Roster</a:t>
             </a:r>
           </a:p>
         </p:txBody>

</xml_diff>